<commit_message>
Correct native chart labels and axes in exported presentation
</commit_message>
<xml_diff>
--- a/prezentare/Prezentare_SDCGIA_v3.pptx
+++ b/prezentare/Prezentare_SDCGIA_v3.pptx
@@ -2,20 +2,20 @@
 <file path=ppt/presentation.xml><?xml version="1.0" encoding="utf-8"?>
 <p:presentation xmlns:p="http://schemas.openxmlformats.org/presentationml/2006/main">
   <p:sldMasterIdLst>
-    <p:sldMasterId xmlns:r="http://schemas.openxmlformats.org/officeDocument/2006/relationships" id="2147483648" r:id="R274eeb377299463d"/>
+    <p:sldMasterId xmlns:r="http://schemas.openxmlformats.org/officeDocument/2006/relationships" id="2147483648" r:id="R85682ade47f046f5"/>
   </p:sldMasterIdLst>
   <p:notesMasterIdLst>
-    <p:notesMasterId xmlns:r="http://schemas.openxmlformats.org/officeDocument/2006/relationships" r:id="R04d8cf6ceeac4576"/>
+    <p:notesMasterId xmlns:r="http://schemas.openxmlformats.org/officeDocument/2006/relationships" r:id="R2e2d5ca8a30c49a0"/>
   </p:notesMasterIdLst>
   <p:sldIdLst>
-    <p:sldId xmlns:r="http://schemas.openxmlformats.org/officeDocument/2006/relationships" id="256" r:id="R2dffc38c39924fb1"/>
-    <p:sldId xmlns:r="http://schemas.openxmlformats.org/officeDocument/2006/relationships" id="257" r:id="R353ee0804d7b466c"/>
-    <p:sldId xmlns:r="http://schemas.openxmlformats.org/officeDocument/2006/relationships" id="258" r:id="Rfad758eb26e044f4"/>
-    <p:sldId xmlns:r="http://schemas.openxmlformats.org/officeDocument/2006/relationships" id="259" r:id="R206a2523ccf64cda"/>
-    <p:sldId xmlns:r="http://schemas.openxmlformats.org/officeDocument/2006/relationships" id="260" r:id="R375954ed5eef48f9"/>
-    <p:sldId xmlns:r="http://schemas.openxmlformats.org/officeDocument/2006/relationships" id="261" r:id="R66c977eddfff4fc4"/>
-    <p:sldId xmlns:r="http://schemas.openxmlformats.org/officeDocument/2006/relationships" id="262" r:id="R9888c372c2784495"/>
-    <p:sldId xmlns:r="http://schemas.openxmlformats.org/officeDocument/2006/relationships" id="263" r:id="Rfc1663ea6f8f477f"/>
+    <p:sldId xmlns:r="http://schemas.openxmlformats.org/officeDocument/2006/relationships" id="256" r:id="Re6a003aa53cc49f3"/>
+    <p:sldId xmlns:r="http://schemas.openxmlformats.org/officeDocument/2006/relationships" id="257" r:id="R3e652cf667204e46"/>
+    <p:sldId xmlns:r="http://schemas.openxmlformats.org/officeDocument/2006/relationships" id="258" r:id="R22158f1ff24e4c36"/>
+    <p:sldId xmlns:r="http://schemas.openxmlformats.org/officeDocument/2006/relationships" id="259" r:id="Rf27733a1b7094498"/>
+    <p:sldId xmlns:r="http://schemas.openxmlformats.org/officeDocument/2006/relationships" id="260" r:id="Re0f0076e882d4fe4"/>
+    <p:sldId xmlns:r="http://schemas.openxmlformats.org/officeDocument/2006/relationships" id="261" r:id="Ree0dd73af0a5414a"/>
+    <p:sldId xmlns:r="http://schemas.openxmlformats.org/officeDocument/2006/relationships" id="262" r:id="Ra34812a1cb7645eb"/>
+    <p:sldId xmlns:r="http://schemas.openxmlformats.org/officeDocument/2006/relationships" id="263" r:id="Rcecc0c7fe8c7498a"/>
   </p:sldIdLst>
   <p:sldSz cx="12192000" cy="6858000"/>
   <p:notesSz cx="6858000" cy="9144000"/>
@@ -3422,12 +3422,12 @@
   </p:cSld>
   <p:clrMap bg1="lt1" tx1="dk1" bg2="lt2" tx2="dk2" accent1="accent1" accent2="accent2" accent3="accent3" accent4="accent4" accent5="accent5" accent6="accent6" hlink="hlink" folHlink="folHlink"/>
   <p:sldLayoutIdLst>
-    <p:sldLayoutId xmlns:r="http://schemas.openxmlformats.org/officeDocument/2006/relationships" id="2147483649" r:id="Re2d8fde588884ab2"/>
-    <p:sldLayoutId xmlns:r="http://schemas.openxmlformats.org/officeDocument/2006/relationships" id="2147483650" r:id="Reb2a499c6ed2490f"/>
-    <p:sldLayoutId xmlns:r="http://schemas.openxmlformats.org/officeDocument/2006/relationships" id="2147483651" r:id="Rb5c9f81ba25d4f05"/>
-    <p:sldLayoutId xmlns:r="http://schemas.openxmlformats.org/officeDocument/2006/relationships" id="2147483652" r:id="Rac76e0f828824310"/>
-    <p:sldLayoutId xmlns:r="http://schemas.openxmlformats.org/officeDocument/2006/relationships" id="2147483653" r:id="R5d0d19b329244a0d"/>
-    <p:sldLayoutId xmlns:r="http://schemas.openxmlformats.org/officeDocument/2006/relationships" id="2147483654" r:id="R2cee116ce896498c"/>
+    <p:sldLayoutId xmlns:r="http://schemas.openxmlformats.org/officeDocument/2006/relationships" id="2147483649" r:id="R0715717d8ad64669"/>
+    <p:sldLayoutId xmlns:r="http://schemas.openxmlformats.org/officeDocument/2006/relationships" id="2147483650" r:id="R55bd5fd37b1c4750"/>
+    <p:sldLayoutId xmlns:r="http://schemas.openxmlformats.org/officeDocument/2006/relationships" id="2147483651" r:id="R99980a46157d4a9f"/>
+    <p:sldLayoutId xmlns:r="http://schemas.openxmlformats.org/officeDocument/2006/relationships" id="2147483652" r:id="R567a4a157918456f"/>
+    <p:sldLayoutId xmlns:r="http://schemas.openxmlformats.org/officeDocument/2006/relationships" id="2147483653" r:id="Rb8bf672dfde1436f"/>
+    <p:sldLayoutId xmlns:r="http://schemas.openxmlformats.org/officeDocument/2006/relationships" id="2147483654" r:id="R3c1b6b4a5e914f4d"/>
   </p:sldLayoutIdLst>
   <p:txStyles>
     <p:titleStyle>
@@ -3981,13 +3981,13 @@
               <c:strCache>
                 <c:ptCount val="3"/>
                 <c:pt idx="0">
-                  <c:v>Antrenare (4.448)</c:v>
+                  <c:v>Antrenare (5.557)</c:v>
                 </c:pt>
                 <c:pt idx="1">
-                  <c:v>Calibrare (955)</c:v>
+                  <c:v>Calibrare (1.194)</c:v>
                 </c:pt>
                 <c:pt idx="2">
-                  <c:v>Test (954)</c:v>
+                  <c:v>Test (1.199)</c:v>
                 </c:pt>
               </c:strCache>
             </c:strRef>
@@ -4029,13 +4029,13 @@
               <c:strCache>
                 <c:ptCount val="3"/>
                 <c:pt idx="0">
-                  <c:v>Antrenare (4.448)</c:v>
+                  <c:v>Antrenare (5.557)</c:v>
                 </c:pt>
                 <c:pt idx="1">
-                  <c:v>Calibrare (955)</c:v>
+                  <c:v>Calibrare (1.194)</c:v>
                 </c:pt>
                 <c:pt idx="2">
-                  <c:v>Test (954)</c:v>
+                  <c:v>Test (1.199)</c:v>
                 </c:pt>
               </c:strCache>
             </c:strRef>
@@ -4098,7 +4098,7 @@
         </c:scaling>
         <c:delete val="0"/>
         <c:axPos val="l"/>
-        <c:numFmt formatCode="General"/>
+        <c:numFmt formatCode="0%"/>
         <c:majorTickMark val="none"/>
         <c:minorTickMark val="none"/>
         <c:spPr>
@@ -4111,7 +4111,7 @@
           <a:lstStyle xmlns:a="http://schemas.openxmlformats.org/drawingml/2006/main"/>
           <a:p xmlns:a="http://schemas.openxmlformats.org/drawingml/2006/main">
             <a:pPr>
-              <a:defRPr sz="1800">
+              <a:defRPr sz="1725">
                 <a:solidFill>
                   <a:srgbClr val="11243A"/>
                 </a:solidFill>
@@ -4146,7 +4146,7 @@
           <a:lstStyle xmlns:a="http://schemas.openxmlformats.org/drawingml/2006/main"/>
           <a:p xmlns:a="http://schemas.openxmlformats.org/drawingml/2006/main">
             <a:pPr>
-              <a:defRPr sz="1500">
+              <a:defRPr sz="1575">
                 <a:solidFill>
                   <a:srgbClr val="5F6F80"/>
                 </a:solidFill>
@@ -4240,7 +4240,7 @@
             <c:numRef>
               <c:f>'Chart Data'!$B$2:$B$5</c:f>
               <c:numCache>
-                <c:formatCode>General</c:formatCode>
+                <c:formatCode>0</c:formatCode>
                 <c:ptCount val="4"/>
                 <c:pt idx="0">
                   <c:v>1635</c:v>
@@ -4309,11 +4309,8 @@
         <c:majorTickMark val="none"/>
         <c:minorTickMark val="none"/>
         <c:spPr>
-          <a:ln xmlns:a="http://schemas.openxmlformats.org/drawingml/2006/main" w="9525">
-            <a:solidFill>
-              <a:srgbClr val="D4D4D4"/>
-            </a:solidFill>
-            <a:prstDash val="solid"/>
+          <a:ln xmlns:a="http://schemas.openxmlformats.org/drawingml/2006/main" w="0">
+            <a:noFill/>
           </a:ln>
         </c:spPr>
         <c:txPr>
@@ -4321,9 +4318,9 @@
           <a:lstStyle xmlns:a="http://schemas.openxmlformats.org/drawingml/2006/main"/>
           <a:p xmlns:a="http://schemas.openxmlformats.org/drawingml/2006/main">
             <a:pPr>
-              <a:defRPr sz="1575">
-                <a:solidFill>
-                  <a:srgbClr val="5F6F80"/>
+              <a:defRPr sz="1950">
+                <a:solidFill>
+                  <a:srgbClr val="11243A"/>
                 </a:solidFill>
                 <a:latin typeface="Arial"/>
                 <a:ea typeface="Arial"/>
@@ -4338,10 +4335,21 @@
         <c:axId val="48672768"/>
         <c:scaling>
           <c:orientation val="minMax"/>
+          <c:max val="2000"/>
+          <c:min val="0"/>
         </c:scaling>
         <c:delete val="0"/>
         <c:axPos val="b"/>
-        <c:numFmt formatCode="General"/>
+        <c:majorGridlines>
+          <c:spPr>
+            <a:ln xmlns:a="http://schemas.openxmlformats.org/drawingml/2006/main" w="9525">
+              <a:solidFill>
+                <a:srgbClr val="D9E0E8"/>
+              </a:solidFill>
+            </a:ln>
+          </c:spPr>
+        </c:majorGridlines>
+        <c:numFmt formatCode="0"/>
         <c:majorTickMark val="none"/>
         <c:minorTickMark val="none"/>
         <c:spPr>
@@ -4354,9 +4362,9 @@
           <a:lstStyle xmlns:a="http://schemas.openxmlformats.org/drawingml/2006/main"/>
           <a:p xmlns:a="http://schemas.openxmlformats.org/drawingml/2006/main">
             <a:pPr>
-              <a:defRPr sz="1950">
-                <a:solidFill>
-                  <a:srgbClr val="11243A"/>
+              <a:defRPr sz="1575">
+                <a:solidFill>
+                  <a:srgbClr val="5F6F80"/>
                 </a:solidFill>
                 <a:latin typeface="Arial"/>
                 <a:ea typeface="Arial"/>
@@ -4367,6 +4375,7 @@
         </c:txPr>
         <c:crossAx val="48650112"/>
         <c:crossBetween val="between"/>
+        <c:majorUnit val="500"/>
       </c:valAx>
       <c:spPr>
         <a:noFill xmlns:a="http://schemas.openxmlformats.org/drawingml/2006/main"/>
@@ -5707,31 +5716,9 @@
           </a:p>
         </p:txBody>
       </p:sp>
-      <p:graphicFrame>
-        <p:nvGraphicFramePr>
-          <p:cNvPr id="4" name="Chart">
-            <a:extLst xmlns:a="http://schemas.openxmlformats.org/drawingml/2006/main">
-              <a:ext uri="{FF2B5EF4-FFF2-40B4-BE49-F238E27FC236}">
-                <a16:creationId xmlns:a16="http://schemas.microsoft.com/office/drawing/2014/main" id="{294EF6D2-F9CB-46B5-9E7D-90AE723420EA}"/>
-              </a:ext>
-            </a:extLst>
-          </p:cNvPr>
-          <p:cNvGraphicFramePr/>
-          <p:nvPr/>
-        </p:nvGraphicFramePr>
-        <p:xfrm>
-          <a:off xmlns:a="http://schemas.openxmlformats.org/drawingml/2006/main" x="571500" y="2047875"/>
-          <a:ext xmlns:a="http://schemas.openxmlformats.org/drawingml/2006/main" cx="7429500" cy="3429000"/>
-        </p:xfrm>
-        <a:graphic xmlns:a="http://schemas.openxmlformats.org/drawingml/2006/main">
-          <a:graphicData uri="http://schemas.openxmlformats.org/drawingml/2006/chart">
-            <c:chart xmlns:r="http://schemas.openxmlformats.org/officeDocument/2006/relationships" xmlns:c="http://schemas.openxmlformats.org/drawingml/2006/chart" r:id="Rce48f1194c114d2f"/>
-          </a:graphicData>
-        </a:graphic>
-      </p:graphicFrame>
       <p:sp>
         <p:nvSpPr>
-          <p:cNvPr id="5" name="">
+          <p:cNvPr id="4" name="">
             <a:extLst xmlns:a="http://schemas.openxmlformats.org/drawingml/2006/main">
               <a:ext uri="{FF2B5EF4-FFF2-40B4-BE49-F238E27FC236}">
                 <a16:creationId xmlns:a16="http://schemas.microsoft.com/office/drawing/2014/main" id="{783841FF-52E6-47AF-A458-B93FC68F4735}"/>
@@ -5887,7 +5874,7 @@
       </p:sp>
       <p:sp>
         <p:nvSpPr>
-          <p:cNvPr id="6" name="">
+          <p:cNvPr id="5" name="">
             <a:extLst xmlns:a="http://schemas.openxmlformats.org/drawingml/2006/main">
               <a:ext uri="{FF2B5EF4-FFF2-40B4-BE49-F238E27FC236}">
                 <a16:creationId xmlns:a16="http://schemas.microsoft.com/office/drawing/2014/main" id="{042D3161-8C18-46D7-B058-6CA55B03FCA1}"/>
@@ -6043,7 +6030,7 @@
       </p:sp>
       <p:sp>
         <p:nvSpPr>
-          <p:cNvPr id="7" name="">
+          <p:cNvPr id="6" name="">
             <a:extLst xmlns:a="http://schemas.openxmlformats.org/drawingml/2006/main">
               <a:ext uri="{FF2B5EF4-FFF2-40B4-BE49-F238E27FC236}">
                 <a16:creationId xmlns:a16="http://schemas.microsoft.com/office/drawing/2014/main" id="{E938AC22-FA82-4E20-81C3-5AAD731635D9}"/>
@@ -6222,7 +6209,7 @@
       </p:sp>
       <p:sp>
         <p:nvSpPr>
-          <p:cNvPr id="8" name="">
+          <p:cNvPr id="7" name="">
             <a:extLst xmlns:a="http://schemas.openxmlformats.org/drawingml/2006/main">
               <a:ext uri="{FF2B5EF4-FFF2-40B4-BE49-F238E27FC236}">
                 <a16:creationId xmlns:a16="http://schemas.microsoft.com/office/drawing/2014/main" id="{5AB3FB8D-EABC-4373-BDF9-FF989D5DA64B}"/>
@@ -6378,7 +6365,7 @@
       </p:sp>
       <p:sp>
         <p:nvSpPr>
-          <p:cNvPr id="9" name="">
+          <p:cNvPr id="8" name="">
             <a:extLst xmlns:a="http://schemas.openxmlformats.org/drawingml/2006/main">
               <a:ext uri="{FF2B5EF4-FFF2-40B4-BE49-F238E27FC236}">
                 <a16:creationId xmlns:a16="http://schemas.microsoft.com/office/drawing/2014/main" id="{D23C0EAE-A915-4683-9323-319D5D621533}"/>
@@ -6532,6 +6519,28 @@
           </a:p>
         </p:txBody>
       </p:sp>
+      <p:graphicFrame>
+        <p:nvGraphicFramePr>
+          <p:cNvPr id="9" name="Chart">
+            <a:extLst xmlns:a="http://schemas.openxmlformats.org/drawingml/2006/main">
+              <a:ext uri="{FF2B5EF4-FFF2-40B4-BE49-F238E27FC236}">
+                <a16:creationId xmlns:a16="http://schemas.microsoft.com/office/drawing/2014/main" id="{5393F9CC-098F-4709-8BEE-4C36A287ECF7}"/>
+              </a:ext>
+            </a:extLst>
+          </p:cNvPr>
+          <p:cNvGraphicFramePr/>
+          <p:nvPr/>
+        </p:nvGraphicFramePr>
+        <p:xfrm>
+          <a:off xmlns:a="http://schemas.openxmlformats.org/drawingml/2006/main" x="571500" y="2047875"/>
+          <a:ext xmlns:a="http://schemas.openxmlformats.org/drawingml/2006/main" cx="7429500" cy="3429000"/>
+        </p:xfrm>
+        <a:graphic xmlns:a="http://schemas.openxmlformats.org/drawingml/2006/main">
+          <a:graphicData uri="http://schemas.openxmlformats.org/drawingml/2006/chart">
+            <c:chart xmlns:r="http://schemas.openxmlformats.org/officeDocument/2006/relationships" xmlns:c="http://schemas.openxmlformats.org/drawingml/2006/chart" r:id="R0b7ff914fd41489e"/>
+          </a:graphicData>
+        </a:graphic>
+      </p:graphicFrame>
     </p:spTree>
     <p:extLst>
       <p:ext uri="{BB962C8B-B14F-4D97-AF65-F5344CB8AC3E}">
@@ -6566,7 +6575,7 @@
           <p:cNvPr id="9" name="">
             <a:extLst xmlns:a="http://schemas.openxmlformats.org/drawingml/2006/main">
               <a:ext uri="{FF2B5EF4-FFF2-40B4-BE49-F238E27FC236}">
-                <a16:creationId xmlns:a16="http://schemas.microsoft.com/office/drawing/2014/main" id="{04E538DC-881B-4E84-8A25-80620C3C6697}"/>
+                <a16:creationId xmlns:a16="http://schemas.microsoft.com/office/drawing/2014/main" id="{8CA2F645-3503-48E6-A4C2-EB39118F62EE}"/>
               </a:ext>
             </a:extLst>
           </p:cNvPr>
@@ -6722,7 +6731,7 @@
           <p:cNvPr id="2" name="">
             <a:extLst xmlns:a="http://schemas.openxmlformats.org/drawingml/2006/main">
               <a:ext uri="{FF2B5EF4-FFF2-40B4-BE49-F238E27FC236}">
-                <a16:creationId xmlns:a16="http://schemas.microsoft.com/office/drawing/2014/main" id="{2864E013-5EF6-4168-96DC-B66C0352E045}"/>
+                <a16:creationId xmlns:a16="http://schemas.microsoft.com/office/drawing/2014/main" id="{53724D7D-8151-460F-BC02-8E928FD95558}"/>
               </a:ext>
             </a:extLst>
           </p:cNvPr>
@@ -6878,7 +6887,7 @@
           <p:cNvPr id="3" name="Chart">
             <a:extLst xmlns:a="http://schemas.openxmlformats.org/drawingml/2006/main">
               <a:ext uri="{FF2B5EF4-FFF2-40B4-BE49-F238E27FC236}">
-                <a16:creationId xmlns:a16="http://schemas.microsoft.com/office/drawing/2014/main" id="{6B61511A-1C79-46EA-A6AC-64A04480A2CD}"/>
+                <a16:creationId xmlns:a16="http://schemas.microsoft.com/office/drawing/2014/main" id="{9770C107-465F-4D2E-BBCB-575C921A910F}"/>
               </a:ext>
             </a:extLst>
           </p:cNvPr>
@@ -6891,7 +6900,7 @@
         </p:xfrm>
         <a:graphic xmlns:a="http://schemas.openxmlformats.org/drawingml/2006/main">
           <a:graphicData uri="http://schemas.openxmlformats.org/drawingml/2006/chart">
-            <c:chart xmlns:r="http://schemas.openxmlformats.org/officeDocument/2006/relationships" xmlns:c="http://schemas.openxmlformats.org/drawingml/2006/chart" r:id="R6df70145231a4da5"/>
+            <c:chart xmlns:r="http://schemas.openxmlformats.org/officeDocument/2006/relationships" xmlns:c="http://schemas.openxmlformats.org/drawingml/2006/chart" r:id="Ra9488ea357d548f2"/>
           </a:graphicData>
         </a:graphic>
       </p:graphicFrame>
@@ -6900,7 +6909,7 @@
           <p:cNvPr id="4" name="">
             <a:extLst xmlns:a="http://schemas.openxmlformats.org/drawingml/2006/main">
               <a:ext uri="{FF2B5EF4-FFF2-40B4-BE49-F238E27FC236}">
-                <a16:creationId xmlns:a16="http://schemas.microsoft.com/office/drawing/2014/main" id="{42F217FD-0EAA-43C1-80E1-DA63464358E4}"/>
+                <a16:creationId xmlns:a16="http://schemas.microsoft.com/office/drawing/2014/main" id="{70BF5332-9361-4717-A958-70B988320110}"/>
               </a:ext>
             </a:extLst>
           </p:cNvPr>
@@ -7056,7 +7065,7 @@
           <p:cNvPr id="5" name="">
             <a:extLst xmlns:a="http://schemas.openxmlformats.org/drawingml/2006/main">
               <a:ext uri="{FF2B5EF4-FFF2-40B4-BE49-F238E27FC236}">
-                <a16:creationId xmlns:a16="http://schemas.microsoft.com/office/drawing/2014/main" id="{31C35DE7-F2ED-4879-BCBA-A71C7B01E369}"/>
+                <a16:creationId xmlns:a16="http://schemas.microsoft.com/office/drawing/2014/main" id="{9471578E-93CD-4A68-94A5-96526A80C6FB}"/>
               </a:ext>
             </a:extLst>
           </p:cNvPr>
@@ -7235,7 +7244,7 @@
           <p:cNvPr id="6" name="">
             <a:extLst xmlns:a="http://schemas.openxmlformats.org/drawingml/2006/main">
               <a:ext uri="{FF2B5EF4-FFF2-40B4-BE49-F238E27FC236}">
-                <a16:creationId xmlns:a16="http://schemas.microsoft.com/office/drawing/2014/main" id="{C085A927-0618-4883-B041-9981C4F6AF7E}"/>
+                <a16:creationId xmlns:a16="http://schemas.microsoft.com/office/drawing/2014/main" id="{1C5042DD-ED86-430A-887D-64746431E1AD}"/>
               </a:ext>
             </a:extLst>
           </p:cNvPr>
@@ -7437,7 +7446,7 @@
           <p:cNvPr id="7" name="">
             <a:extLst xmlns:a="http://schemas.openxmlformats.org/drawingml/2006/main">
               <a:ext uri="{FF2B5EF4-FFF2-40B4-BE49-F238E27FC236}">
-                <a16:creationId xmlns:a16="http://schemas.microsoft.com/office/drawing/2014/main" id="{394AE2D8-070E-4249-B36B-0E9C08D280CB}"/>
+                <a16:creationId xmlns:a16="http://schemas.microsoft.com/office/drawing/2014/main" id="{01EFDD85-55D9-44B2-B257-6DAEC8A41D1F}"/>
               </a:ext>
             </a:extLst>
           </p:cNvPr>
@@ -7593,7 +7602,7 @@
           <p:cNvPr id="8" name="">
             <a:extLst xmlns:a="http://schemas.openxmlformats.org/drawingml/2006/main">
               <a:ext uri="{FF2B5EF4-FFF2-40B4-BE49-F238E27FC236}">
-                <a16:creationId xmlns:a16="http://schemas.microsoft.com/office/drawing/2014/main" id="{3D495F03-AE19-41C5-B47F-FAB300197BC9}"/>
+                <a16:creationId xmlns:a16="http://schemas.microsoft.com/office/drawing/2014/main" id="{0C784244-CF15-40EE-B345-E02EDA36AC17}"/>
               </a:ext>
             </a:extLst>
           </p:cNvPr>
@@ -11143,7 +11152,7 @@
           <p:cNvPr id="6" name="">
             <a:extLst xmlns:a="http://schemas.openxmlformats.org/drawingml/2006/main">
               <a:ext uri="{FF2B5EF4-FFF2-40B4-BE49-F238E27FC236}">
-                <a16:creationId xmlns:a16="http://schemas.microsoft.com/office/drawing/2014/main" id="{0AB03400-5B4D-4C3A-90D0-4B0E015E7207}"/>
+                <a16:creationId xmlns:a16="http://schemas.microsoft.com/office/drawing/2014/main" id="{23C02531-4A5E-405B-BBAD-34FCD3C30F10}"/>
               </a:ext>
             </a:extLst>
           </p:cNvPr>
@@ -11299,7 +11308,7 @@
           <p:cNvPr id="2" name="">
             <a:extLst xmlns:a="http://schemas.openxmlformats.org/drawingml/2006/main">
               <a:ext uri="{FF2B5EF4-FFF2-40B4-BE49-F238E27FC236}">
-                <a16:creationId xmlns:a16="http://schemas.microsoft.com/office/drawing/2014/main" id="{1C292F7C-10BA-4A66-879E-946CA78E5019}"/>
+                <a16:creationId xmlns:a16="http://schemas.microsoft.com/office/drawing/2014/main" id="{B5497627-A669-4486-AC39-3034682C1D41}"/>
               </a:ext>
             </a:extLst>
           </p:cNvPr>
@@ -11455,7 +11464,7 @@
           <p:cNvPr id="3" name="">
             <a:extLst xmlns:a="http://schemas.openxmlformats.org/drawingml/2006/main">
               <a:ext uri="{FF2B5EF4-FFF2-40B4-BE49-F238E27FC236}">
-                <a16:creationId xmlns:a16="http://schemas.microsoft.com/office/drawing/2014/main" id="{132E469C-B1F6-467A-9F51-464B8E4EB91E}"/>
+                <a16:creationId xmlns:a16="http://schemas.microsoft.com/office/drawing/2014/main" id="{B17B110F-2CA7-457D-A61A-2F1E56E967A1}"/>
               </a:ext>
             </a:extLst>
           </p:cNvPr>
@@ -12298,7 +12307,7 @@
           <p:cNvPr id="4" name="">
             <a:extLst xmlns:a="http://schemas.openxmlformats.org/drawingml/2006/main">
               <a:ext uri="{FF2B5EF4-FFF2-40B4-BE49-F238E27FC236}">
-                <a16:creationId xmlns:a16="http://schemas.microsoft.com/office/drawing/2014/main" id="{D724853F-8AA9-45FA-BAF0-D4B668177DFC}"/>
+                <a16:creationId xmlns:a16="http://schemas.microsoft.com/office/drawing/2014/main" id="{D429F9DD-3AD1-4C4F-AF7A-041C44052AC6}"/>
               </a:ext>
             </a:extLst>
           </p:cNvPr>
@@ -12454,7 +12463,7 @@
           <p:cNvPr id="5" name="">
             <a:extLst xmlns:a="http://schemas.openxmlformats.org/drawingml/2006/main">
               <a:ext uri="{FF2B5EF4-FFF2-40B4-BE49-F238E27FC236}">
-                <a16:creationId xmlns:a16="http://schemas.microsoft.com/office/drawing/2014/main" id="{03061E79-999D-4562-BC19-0B74088F68D0}"/>
+                <a16:creationId xmlns:a16="http://schemas.microsoft.com/office/drawing/2014/main" id="{15BA135E-5D1E-483B-A515-E228E3F31345}"/>
               </a:ext>
             </a:extLst>
           </p:cNvPr>
@@ -12639,7 +12648,7 @@
           <p:cNvPr id="6" name="">
             <a:extLst xmlns:a="http://schemas.openxmlformats.org/drawingml/2006/main">
               <a:ext uri="{FF2B5EF4-FFF2-40B4-BE49-F238E27FC236}">
-                <a16:creationId xmlns:a16="http://schemas.microsoft.com/office/drawing/2014/main" id="{73609E8E-CE27-46E5-816F-FE0934750E1D}"/>
+                <a16:creationId xmlns:a16="http://schemas.microsoft.com/office/drawing/2014/main" id="{427CE1C5-CA91-482E-9C91-93A2E79805C2}"/>
               </a:ext>
             </a:extLst>
           </p:cNvPr>
@@ -12795,7 +12804,7 @@
           <p:cNvPr id="2" name="">
             <a:extLst xmlns:a="http://schemas.openxmlformats.org/drawingml/2006/main">
               <a:ext uri="{FF2B5EF4-FFF2-40B4-BE49-F238E27FC236}">
-                <a16:creationId xmlns:a16="http://schemas.microsoft.com/office/drawing/2014/main" id="{A2170D2C-C682-4FBC-832D-E6A73AC42D4D}"/>
+                <a16:creationId xmlns:a16="http://schemas.microsoft.com/office/drawing/2014/main" id="{0655E491-FBA1-4FB3-BB21-EE2F0EA10E69}"/>
               </a:ext>
             </a:extLst>
           </p:cNvPr>
@@ -12951,7 +12960,7 @@
           <p:cNvPr id="3" name="">
             <a:extLst xmlns:a="http://schemas.openxmlformats.org/drawingml/2006/main">
               <a:ext uri="{FF2B5EF4-FFF2-40B4-BE49-F238E27FC236}">
-                <a16:creationId xmlns:a16="http://schemas.microsoft.com/office/drawing/2014/main" id="{F403EBB5-8D1C-4637-95A1-877FB31B84FD}"/>
+                <a16:creationId xmlns:a16="http://schemas.microsoft.com/office/drawing/2014/main" id="{2781C757-0861-4561-9BC3-40B84876619B}"/>
               </a:ext>
             </a:extLst>
           </p:cNvPr>
@@ -13572,7 +13581,7 @@
           <p:cNvPr id="4" name="">
             <a:extLst xmlns:a="http://schemas.openxmlformats.org/drawingml/2006/main">
               <a:ext uri="{FF2B5EF4-FFF2-40B4-BE49-F238E27FC236}">
-                <a16:creationId xmlns:a16="http://schemas.microsoft.com/office/drawing/2014/main" id="{0006BC89-126E-4E11-B2AB-022ADD228607}"/>
+                <a16:creationId xmlns:a16="http://schemas.microsoft.com/office/drawing/2014/main" id="{4D2DF681-E85A-45D7-9F8F-49DDB55B0A3D}"/>
               </a:ext>
             </a:extLst>
           </p:cNvPr>
@@ -13728,7 +13737,7 @@
           <p:cNvPr id="5" name="">
             <a:extLst xmlns:a="http://schemas.openxmlformats.org/drawingml/2006/main">
               <a:ext uri="{FF2B5EF4-FFF2-40B4-BE49-F238E27FC236}">
-                <a16:creationId xmlns:a16="http://schemas.microsoft.com/office/drawing/2014/main" id="{FEA1F9C1-CB2F-4960-B084-2F1EACA7CA9E}"/>
+                <a16:creationId xmlns:a16="http://schemas.microsoft.com/office/drawing/2014/main" id="{79AD16D6-7BD9-48B4-A3CF-FF01BCEA0A10}"/>
               </a:ext>
             </a:extLst>
           </p:cNvPr>

</xml_diff>